<commit_message>
fix: normalize country codes to ISO in facility data
Facilities had mixed formats ("United States" vs "US", "UK" vs "GB", etc.)
which prevented MarketSizeCard from matching market-sizes.json keys.
All 17 full-name/variant codes normalized to ISO 2-letter codes.

Co-Authored-By: Claude Opus 4.6 (1M context) <noreply@anthropic.com>
</commit_message>
<xml_diff>
--- a/GeoCenter_Analytics_Pitch.pptx
+++ b/GeoCenter_Analytics_Pitch.pptx
@@ -2502,8 +2502,8 @@
         </p:nvSpPr>
         <p:spPr>
           <a:xfrm>
-            <a:off x="5029200" y="1371600"/>
-            <a:ext cx="3657600" cy="640080"/>
+            <a:off x="5029200" y="1325880"/>
+            <a:ext cx="3657600" cy="594360"/>
           </a:xfrm>
           <a:prstGeom prst="rect">
             <a:avLst/>
@@ -2527,7 +2527,7 @@
                 <a:ea typeface="Georgia" pitchFamily="34" charset="-122"/>
                 <a:cs typeface="Georgia" pitchFamily="34" charset="-120"/>
               </a:rPr>
-              <a:t>$6.65B</a:t>
+              <a:t>$10.8B</a:t>
             </a:r>
             <a:endParaRPr lang="en-US" sz="4200" dirty="0"/>
           </a:p>
@@ -2541,7 +2541,7 @@
         </p:nvSpPr>
         <p:spPr>
           <a:xfrm>
-            <a:off x="5029200" y="1965960"/>
+            <a:off x="5029200" y="1874520"/>
             <a:ext cx="3657600" cy="274320"/>
           </a:xfrm>
           <a:prstGeom prst="rect">
@@ -2566,7 +2566,7 @@
                 <a:ea typeface="Calibri" pitchFamily="34" charset="-122"/>
                 <a:cs typeface="Calibri" pitchFamily="34" charset="-120"/>
               </a:rPr>
-              <a:t>Global liquid cooling market (2025)</a:t>
+              <a:t>Total data centre cooling market (2025) — CAGR 15.1%</a:t>
             </a:r>
             <a:endParaRPr lang="en-US" sz="1000" dirty="0"/>
           </a:p>
@@ -2580,28 +2580,28 @@
         </p:nvSpPr>
         <p:spPr>
           <a:xfrm>
+            <a:off x="5029200" y="2194560"/>
+            <a:ext cx="3200400" cy="13716"/>
+          </a:xfrm>
+          <a:prstGeom prst="rect">
+            <a:avLst/>
+          </a:prstGeom>
+          <a:solidFill>
+            <a:srgbClr val="D0D8E0"/>
+          </a:solidFill>
+          <a:ln/>
+        </p:spPr>
+      </p:sp>
+      <p:sp>
+        <p:nvSpPr>
+          <p:cNvPr id="14" name="Text 12"/>
+          <p:cNvSpPr/>
+          <p:nvPr/>
+        </p:nvSpPr>
+        <p:spPr>
+          <a:xfrm>
             <a:off x="5029200" y="2331720"/>
-            <a:ext cx="3200400" cy="13716"/>
-          </a:xfrm>
-          <a:prstGeom prst="rect">
-            <a:avLst/>
-          </a:prstGeom>
-          <a:solidFill>
-            <a:srgbClr val="D0D8E0"/>
-          </a:solidFill>
-          <a:ln/>
-        </p:spPr>
-      </p:sp>
-      <p:sp>
-        <p:nvSpPr>
-          <p:cNvPr id="14" name="Text 12"/>
-          <p:cNvSpPr/>
-          <p:nvPr/>
-        </p:nvSpPr>
-        <p:spPr>
-          <a:xfrm>
-            <a:off x="5029200" y="2514600"/>
-            <a:ext cx="1188720" cy="411480"/>
+            <a:ext cx="1280160" cy="365760"/>
           </a:xfrm>
           <a:prstGeom prst="rect">
             <a:avLst/>
@@ -2625,7 +2625,7 @@
                 <a:ea typeface="Georgia" pitchFamily="34" charset="-122"/>
                 <a:cs typeface="Georgia" pitchFamily="34" charset="-120"/>
               </a:rPr>
-              <a:t>34%</a:t>
+              <a:t>$5.52B</a:t>
             </a:r>
             <a:endParaRPr lang="en-US" sz="2000" dirty="0"/>
           </a:p>
@@ -2639,8 +2639,8 @@
         </p:nvSpPr>
         <p:spPr>
           <a:xfrm>
-            <a:off x="6217920" y="2514600"/>
-            <a:ext cx="2468880" cy="411480"/>
+            <a:off x="6309360" y="2331720"/>
+            <a:ext cx="2377440" cy="365760"/>
           </a:xfrm>
           <a:prstGeom prst="rect">
             <a:avLst/>
@@ -2664,7 +2664,7 @@
                 <a:ea typeface="Calibri" pitchFamily="34" charset="-122"/>
                 <a:cs typeface="Calibri" pitchFamily="34" charset="-120"/>
               </a:rPr>
-              <a:t>North America</a:t>
+              <a:t>Liquid Cooling</a:t>
             </a:r>
             <a:endParaRPr lang="en-US" sz="1100" dirty="0"/>
           </a:p>
@@ -2681,7 +2681,7 @@
                 <a:ea typeface="Calibri" pitchFamily="34" charset="-122"/>
                 <a:cs typeface="Calibri" pitchFamily="34" charset="-120"/>
               </a:rPr>
-              <a:t>of global immersion cooling market</a:t>
+              <a:t>CAGR 22.65% through 2031</a:t>
             </a:r>
             <a:endParaRPr lang="en-US" sz="1100" dirty="0"/>
           </a:p>
@@ -2695,8 +2695,8 @@
         </p:nvSpPr>
         <p:spPr>
           <a:xfrm>
-            <a:off x="5029200" y="3017520"/>
-            <a:ext cx="1188720" cy="411480"/>
+            <a:off x="5029200" y="2788920"/>
+            <a:ext cx="1280160" cy="365760"/>
           </a:xfrm>
           <a:prstGeom prst="rect">
             <a:avLst/>
@@ -2720,7 +2720,7 @@
                 <a:ea typeface="Georgia" pitchFamily="34" charset="-122"/>
                 <a:cs typeface="Georgia" pitchFamily="34" charset="-120"/>
               </a:rPr>
-              <a:t>$1.3B</a:t>
+              <a:t>26.6%</a:t>
             </a:r>
             <a:endParaRPr lang="en-US" sz="2000" dirty="0"/>
           </a:p>
@@ -2734,8 +2734,8 @@
         </p:nvSpPr>
         <p:spPr>
           <a:xfrm>
-            <a:off x="6217920" y="3017520"/>
-            <a:ext cx="2468880" cy="411480"/>
+            <a:off x="6309360" y="2788920"/>
+            <a:ext cx="2377440" cy="365760"/>
           </a:xfrm>
           <a:prstGeom prst="rect">
             <a:avLst/>
@@ -2759,7 +2759,7 @@
                 <a:ea typeface="Calibri" pitchFamily="34" charset="-122"/>
                 <a:cs typeface="Calibri" pitchFamily="34" charset="-120"/>
               </a:rPr>
-              <a:t>U.S. Liquid Cooling</a:t>
+              <a:t>Immersion Cooling</a:t>
             </a:r>
             <a:endParaRPr lang="en-US" sz="1100" dirty="0"/>
           </a:p>
@@ -2776,7 +2776,7 @@
                 <a:ea typeface="Calibri" pitchFamily="34" charset="-122"/>
                 <a:cs typeface="Calibri" pitchFamily="34" charset="-120"/>
               </a:rPr>
-              <a:t>segment value</a:t>
+              <a:t>CAGR — fastest-growing segment</a:t>
             </a:r>
             <a:endParaRPr lang="en-US" sz="1100" dirty="0"/>
           </a:p>
@@ -2784,14 +2784,34 @@
       </p:sp>
       <p:sp>
         <p:nvSpPr>
-          <p:cNvPr id="18" name="Text 16"/>
-          <p:cNvSpPr/>
-          <p:nvPr/>
-        </p:nvSpPr>
-        <p:spPr>
-          <a:xfrm>
-            <a:off x="5029200" y="3520440"/>
-            <a:ext cx="1188720" cy="411480"/>
+          <p:cNvPr id="18" name="Shape 16"/>
+          <p:cNvSpPr/>
+          <p:nvPr/>
+        </p:nvSpPr>
+        <p:spPr>
+          <a:xfrm>
+            <a:off x="5029200" y="3246120"/>
+            <a:ext cx="3200400" cy="13716"/>
+          </a:xfrm>
+          <a:prstGeom prst="rect">
+            <a:avLst/>
+          </a:prstGeom>
+          <a:solidFill>
+            <a:srgbClr val="D0D8E0"/>
+          </a:solidFill>
+          <a:ln/>
+        </p:spPr>
+      </p:sp>
+      <p:sp>
+        <p:nvSpPr>
+          <p:cNvPr id="19" name="Text 17"/>
+          <p:cNvSpPr/>
+          <p:nvPr/>
+        </p:nvSpPr>
+        <p:spPr>
+          <a:xfrm>
+            <a:off x="5029200" y="3383280"/>
+            <a:ext cx="1280160" cy="365760"/>
           </a:xfrm>
           <a:prstGeom prst="rect">
             <a:avLst/>
@@ -2815,7 +2835,7 @@
                 <a:ea typeface="Georgia" pitchFamily="34" charset="-122"/>
                 <a:cs typeface="Georgia" pitchFamily="34" charset="-120"/>
               </a:rPr>
-              <a:t>28%</a:t>
+              <a:t>40.3%</a:t>
             </a:r>
             <a:endParaRPr lang="en-US" sz="2000" dirty="0"/>
           </a:p>
@@ -2823,14 +2843,14 @@
       </p:sp>
       <p:sp>
         <p:nvSpPr>
-          <p:cNvPr id="19" name="Text 17"/>
-          <p:cNvSpPr/>
-          <p:nvPr/>
-        </p:nvSpPr>
-        <p:spPr>
-          <a:xfrm>
-            <a:off x="6217920" y="3520440"/>
-            <a:ext cx="2468880" cy="411480"/>
+          <p:cNvPr id="20" name="Text 18"/>
+          <p:cNvSpPr/>
+          <p:nvPr/>
+        </p:nvSpPr>
+        <p:spPr>
+          <a:xfrm>
+            <a:off x="6309360" y="3383280"/>
+            <a:ext cx="2377440" cy="365760"/>
           </a:xfrm>
           <a:prstGeom prst="rect">
             <a:avLst/>
@@ -2854,7 +2874,7 @@
                 <a:ea typeface="Calibri" pitchFamily="34" charset="-122"/>
                 <a:cs typeface="Calibri" pitchFamily="34" charset="-120"/>
               </a:rPr>
-              <a:t>Europe</a:t>
+              <a:t>North America</a:t>
             </a:r>
             <a:endParaRPr lang="en-US" sz="1100" dirty="0"/>
           </a:p>
@@ -2871,7 +2891,7 @@
                 <a:ea typeface="Calibri" pitchFamily="34" charset="-122"/>
                 <a:cs typeface="Calibri" pitchFamily="34" charset="-120"/>
               </a:rPr>
-              <a:t>of global market share</a:t>
+              <a:t>of global immersion cooling market</a:t>
             </a:r>
             <a:endParaRPr lang="en-US" sz="1100" dirty="0"/>
           </a:p>
@@ -2879,34 +2899,53 @@
       </p:sp>
       <p:sp>
         <p:nvSpPr>
-          <p:cNvPr id="20" name="Shape 18"/>
-          <p:cNvSpPr/>
-          <p:nvPr/>
-        </p:nvSpPr>
-        <p:spPr>
-          <a:xfrm>
-            <a:off x="5029200" y="4069080"/>
-            <a:ext cx="3657600" cy="548640"/>
-          </a:xfrm>
-          <a:prstGeom prst="rect">
-            <a:avLst/>
-          </a:prstGeom>
-          <a:solidFill>
-            <a:srgbClr val="EEF4F8"/>
-          </a:solidFill>
-          <a:ln/>
-        </p:spPr>
-      </p:sp>
-      <p:sp>
-        <p:nvSpPr>
           <p:cNvPr id="21" name="Text 19"/>
           <p:cNvSpPr/>
           <p:nvPr/>
         </p:nvSpPr>
         <p:spPr>
           <a:xfrm>
-            <a:off x="5212080" y="4114800"/>
-            <a:ext cx="3291840" cy="457200"/>
+            <a:off x="5029200" y="3840480"/>
+            <a:ext cx="1280160" cy="365760"/>
+          </a:xfrm>
+          <a:prstGeom prst="rect">
+            <a:avLst/>
+          </a:prstGeom>
+          <a:noFill/>
+          <a:ln/>
+        </p:spPr>
+        <p:txBody>
+          <a:bodyPr wrap="square" lIns="0" tIns="0" rIns="0" bIns="0" rtlCol="0" anchor="ctr"/>
+          <a:lstStyle/>
+          <a:p>
+            <a:pPr indent="0" marL="0">
+              <a:buNone/>
+            </a:pPr>
+            <a:r>
+              <a:rPr lang="en-US" sz="2000" b="1" dirty="0">
+                <a:solidFill>
+                  <a:srgbClr val="0B2545"/>
+                </a:solidFill>
+                <a:latin typeface="Georgia" pitchFamily="34" charset="0"/>
+                <a:ea typeface="Georgia" pitchFamily="34" charset="-122"/>
+                <a:cs typeface="Georgia" pitchFamily="34" charset="-120"/>
+              </a:rPr>
+              <a:t>28%</a:t>
+            </a:r>
+            <a:endParaRPr lang="en-US" sz="2000" dirty="0"/>
+          </a:p>
+        </p:txBody>
+      </p:sp>
+      <p:sp>
+        <p:nvSpPr>
+          <p:cNvPr id="22" name="Text 20"/>
+          <p:cNvSpPr/>
+          <p:nvPr/>
+        </p:nvSpPr>
+        <p:spPr>
+          <a:xfrm>
+            <a:off x="6309360" y="3840480"/>
+            <a:ext cx="2377440" cy="365760"/>
           </a:xfrm>
           <a:prstGeom prst="rect">
             <a:avLst/>
@@ -2930,21 +2969,24 @@
                 <a:ea typeface="Calibri" pitchFamily="34" charset="-122"/>
                 <a:cs typeface="Calibri" pitchFamily="34" charset="-120"/>
               </a:rPr>
-              <a:t>Target PUE: 1.04 – 1.2  </a:t>
-            </a:r>
-            <a:pPr indent="0" marL="0">
-              <a:buNone/>
-            </a:pPr>
-            <a:r>
-              <a:rPr lang="en-US" sz="1000" dirty="0">
-                <a:solidFill>
-                  <a:srgbClr val="3A5A7C"/>
+              <a:t>Europe</a:t>
+            </a:r>
+            <a:endParaRPr lang="en-US" sz="1100" dirty="0"/>
+          </a:p>
+          <a:p>
+            <a:pPr indent="0" marL="0">
+              <a:buNone/>
+            </a:pPr>
+            <a:r>
+              <a:rPr lang="en-US" sz="950" dirty="0">
+                <a:solidFill>
+                  <a:srgbClr val="6A8FAB"/>
                 </a:solidFill>
                 <a:latin typeface="Calibri" pitchFamily="34" charset="0"/>
                 <a:ea typeface="Calibri" pitchFamily="34" charset="-122"/>
                 <a:cs typeface="Calibri" pitchFamily="34" charset="-120"/>
               </a:rPr>
-              <a:t>| Liquid: 1.1–1.2  |  Immersion: 1.02–1.10</a:t>
+              <a:t>of global market share</a:t>
             </a:r>
             <a:endParaRPr lang="en-US" sz="1100" dirty="0"/>
           </a:p>
@@ -2952,14 +2994,34 @@
       </p:sp>
       <p:sp>
         <p:nvSpPr>
-          <p:cNvPr id="22" name="Text 20"/>
-          <p:cNvSpPr/>
-          <p:nvPr/>
-        </p:nvSpPr>
-        <p:spPr>
-          <a:xfrm>
-            <a:off x="640080" y="4709160"/>
-            <a:ext cx="7863840" cy="274320"/>
+          <p:cNvPr id="23" name="Shape 21"/>
+          <p:cNvSpPr/>
+          <p:nvPr/>
+        </p:nvSpPr>
+        <p:spPr>
+          <a:xfrm>
+            <a:off x="5029200" y="4297680"/>
+            <a:ext cx="3657600" cy="411480"/>
+          </a:xfrm>
+          <a:prstGeom prst="rect">
+            <a:avLst/>
+          </a:prstGeom>
+          <a:solidFill>
+            <a:srgbClr val="EEF4F8"/>
+          </a:solidFill>
+          <a:ln/>
+        </p:spPr>
+      </p:sp>
+      <p:sp>
+        <p:nvSpPr>
+          <p:cNvPr id="24" name="Text 22"/>
+          <p:cNvSpPr/>
+          <p:nvPr/>
+        </p:nvSpPr>
+        <p:spPr>
+          <a:xfrm>
+            <a:off x="5166360" y="4325112"/>
+            <a:ext cx="3383280" cy="347472"/>
           </a:xfrm>
           <a:prstGeom prst="rect">
             <a:avLst/>
@@ -2975,15 +3037,68 @@
               <a:buNone/>
             </a:pPr>
             <a:r>
-              <a:rPr lang="en-US" sz="900" dirty="0">
-                <a:solidFill>
-                  <a:srgbClr val="8EAFC0"/>
+              <a:rPr lang="en-US" sz="1000" b="1" dirty="0">
+                <a:solidFill>
+                  <a:srgbClr val="0B2545"/>
                 </a:solidFill>
                 <a:latin typeface="Calibri" pitchFamily="34" charset="0"/>
                 <a:ea typeface="Calibri" pitchFamily="34" charset="-122"/>
                 <a:cs typeface="Calibri" pitchFamily="34" charset="-120"/>
               </a:rPr>
-              <a:t>Segmented by region, capacity, and colour-coded for presentation.</a:t>
+              <a:t>Target PUE: 1.04 – 1.2  </a:t>
+            </a:r>
+            <a:pPr indent="0" marL="0">
+              <a:buNone/>
+            </a:pPr>
+            <a:r>
+              <a:rPr lang="en-US" sz="950" dirty="0">
+                <a:solidFill>
+                  <a:srgbClr val="3A5A7C"/>
+                </a:solidFill>
+                <a:latin typeface="Calibri" pitchFamily="34" charset="0"/>
+                <a:ea typeface="Calibri" pitchFamily="34" charset="-122"/>
+                <a:cs typeface="Calibri" pitchFamily="34" charset="-120"/>
+              </a:rPr>
+              <a:t>| Liquid: 1.1–1.2  |  Immersion: 1.02–1.10</a:t>
+            </a:r>
+            <a:endParaRPr lang="en-US" sz="1000" dirty="0"/>
+          </a:p>
+        </p:txBody>
+      </p:sp>
+      <p:sp>
+        <p:nvSpPr>
+          <p:cNvPr id="25" name="Text 23"/>
+          <p:cNvSpPr/>
+          <p:nvPr/>
+        </p:nvSpPr>
+        <p:spPr>
+          <a:xfrm>
+            <a:off x="640080" y="4709160"/>
+            <a:ext cx="7863840" cy="274320"/>
+          </a:xfrm>
+          <a:prstGeom prst="rect">
+            <a:avLst/>
+          </a:prstGeom>
+          <a:noFill/>
+          <a:ln/>
+        </p:spPr>
+        <p:txBody>
+          <a:bodyPr wrap="square" rtlCol="0" anchor="ctr"/>
+          <a:lstStyle/>
+          <a:p>
+            <a:pPr indent="0" marL="0">
+              <a:buNone/>
+            </a:pPr>
+            <a:r>
+              <a:rPr lang="en-US" sz="900" dirty="0">
+                <a:solidFill>
+                  <a:srgbClr val="8EAFC0"/>
+                </a:solidFill>
+                <a:latin typeface="Calibri" pitchFamily="34" charset="0"/>
+                <a:ea typeface="Calibri" pitchFamily="34" charset="-122"/>
+                <a:cs typeface="Calibri" pitchFamily="34" charset="-120"/>
+              </a:rPr>
+              <a:t>Source: Mordor Intelligence (2025–2031)  |  Segmented by region, capacity, and colour-coded for presentation.</a:t>
             </a:r>
             <a:endParaRPr lang="en-US" sz="900" dirty="0"/>
           </a:p>

</xml_diff>